<commit_message>
Move PyTorch framework choice slide to main slide deck
</commit_message>
<xml_diff>
--- a/machine_learning_with_python.pptx
+++ b/machine_learning_with_python.pptx
@@ -5,7 +5,7 @@
     <p:sldMasterId id="2147483660" r:id="rId1"/>
   </p:sldMasterIdLst>
   <p:notesMasterIdLst>
-    <p:notesMasterId r:id="rId67"/>
+    <p:notesMasterId r:id="rId68"/>
   </p:notesMasterIdLst>
   <p:sldIdLst>
     <p:sldId id="257" r:id="rId2"/>
@@ -64,15 +64,16 @@
     <p:sldId id="278" r:id="rId55"/>
     <p:sldId id="269" r:id="rId56"/>
     <p:sldId id="282" r:id="rId57"/>
-    <p:sldId id="284" r:id="rId58"/>
-    <p:sldId id="769" r:id="rId59"/>
-    <p:sldId id="770" r:id="rId60"/>
-    <p:sldId id="786" r:id="rId61"/>
-    <p:sldId id="283" r:id="rId62"/>
-    <p:sldId id="286" r:id="rId63"/>
-    <p:sldId id="287" r:id="rId64"/>
-    <p:sldId id="285" r:id="rId65"/>
-    <p:sldId id="288" r:id="rId66"/>
+    <p:sldId id="787" r:id="rId58"/>
+    <p:sldId id="284" r:id="rId59"/>
+    <p:sldId id="769" r:id="rId60"/>
+    <p:sldId id="770" r:id="rId61"/>
+    <p:sldId id="786" r:id="rId62"/>
+    <p:sldId id="283" r:id="rId63"/>
+    <p:sldId id="286" r:id="rId64"/>
+    <p:sldId id="287" r:id="rId65"/>
+    <p:sldId id="285" r:id="rId66"/>
+    <p:sldId id="288" r:id="rId67"/>
   </p:sldIdLst>
   <p:sldSz cx="12192000" cy="6858000"/>
   <p:notesSz cx="6858000" cy="9144000"/>
@@ -244,6 +245,7 @@
             <p14:sldId id="278"/>
             <p14:sldId id="269"/>
             <p14:sldId id="282"/>
+            <p14:sldId id="787"/>
           </p14:sldIdLst>
         </p14:section>
         <p14:section name="Conclusions" id="{A9B2E2E8-EE28-4C08-9F33-76B98F6A83CB}">
@@ -354,7 +356,7 @@
           <a:p>
             <a:fld id="{DBF5F7A3-80FA-4DE8-9E10-D5FD6AAF4E4C}" type="datetimeFigureOut">
               <a:rPr lang="en-US" smtClean="0"/>
-              <a:t>2026-08-18</a:t>
+              <a:t>2026-09-08</a:t>
             </a:fld>
             <a:endParaRPr lang="en-US"/>
           </a:p>
@@ -711,6 +713,128 @@
 </p:notes>
 </file>
 
+<file path=ppt/notesSlides/notesSlide2.xml><?xml version="1.0" encoding="utf-8"?>
+<p:notes xmlns:a="http://schemas.openxmlformats.org/drawingml/2006/main" xmlns:r="http://schemas.openxmlformats.org/officeDocument/2006/relationships" xmlns:p="http://schemas.openxmlformats.org/presentationml/2006/main">
+  <p:cSld>
+    <p:spTree>
+      <p:nvGrpSpPr>
+        <p:cNvPr id="1" name=""/>
+        <p:cNvGrpSpPr/>
+        <p:nvPr/>
+      </p:nvGrpSpPr>
+      <p:grpSpPr>
+        <a:xfrm>
+          <a:off x="0" y="0"/>
+          <a:ext cx="0" cy="0"/>
+          <a:chOff x="0" y="0"/>
+          <a:chExt cx="0" cy="0"/>
+        </a:xfrm>
+      </p:grpSpPr>
+      <p:sp>
+        <p:nvSpPr>
+          <p:cNvPr id="2" name="Slide Image Placeholder 1"/>
+          <p:cNvSpPr>
+            <a:spLocks noGrp="1" noRot="1" noChangeAspect="1"/>
+          </p:cNvSpPr>
+          <p:nvPr>
+            <p:ph type="sldImg"/>
+          </p:nvPr>
+        </p:nvSpPr>
+        <p:spPr/>
+      </p:sp>
+      <p:sp>
+        <p:nvSpPr>
+          <p:cNvPr id="3" name="Notes Placeholder 2"/>
+          <p:cNvSpPr>
+            <a:spLocks noGrp="1"/>
+          </p:cNvSpPr>
+          <p:nvPr>
+            <p:ph type="body" idx="1"/>
+          </p:nvPr>
+        </p:nvSpPr>
+        <p:spPr/>
+        <p:txBody>
+          <a:bodyPr/>
+          <a:lstStyle/>
+          <a:p>
+            <a:r>
+              <a:t>Ask participants to apply the decision test before revealing the three choices.</a:t>
+            </a:r>
+          </a:p>
+          <a:p>
+            <a:r>
+              <a:t>The boundary is whether training machinery is infrastructure or part of the experimental variable—not the researcher’s discipline.</a:t>
+            </a:r>
+          </a:p>
+          <a:p>
+            <a:r>
+              <a:t>Lightning remains PyTorch: keep models, losses, data and scientific metrics as ordinary PyTorch components.</a:t>
+            </a:r>
+          </a:p>
+          <a:p>
+            <a:r>
+              <a:t>Fabric is the middle ground when the researcher wants distributed setup but needs the loop to remain explicit.</a:t>
+            </a:r>
+          </a:p>
+          <a:p>
+            <a:r>
+              <a:t>For experimental distributed APIs such as Lightning ModelParallelStrategy/FSDP2, pin compatible framework versions.</a:t>
+            </a:r>
+          </a:p>
+          <a:p>
+            <a:r>
+              <a:t>[Sources]</a:t>
+            </a:r>
+          </a:p>
+          <a:p>
+            <a:r>
+              <a:t>- https://lightning.ai/docs/pytorch/stable/common/lightning_module.html</a:t>
+            </a:r>
+          </a:p>
+          <a:p>
+            <a:r>
+              <a:t>- https://lightning.ai/docs/fabric/stable/</a:t>
+            </a:r>
+          </a:p>
+          <a:p>
+            <a:r>
+              <a:t>- https://lightning.ai/docs/pytorch/stable/api/lightning.pytorch.strategies.ModelParallelStrategy.html</a:t>
+            </a:r>
+          </a:p>
+          <a:p>
+            <a:r>
+              <a:t>[/Sources]</a:t>
+            </a:r>
+          </a:p>
+        </p:txBody>
+      </p:sp>
+      <p:sp>
+        <p:nvSpPr>
+          <p:cNvPr id="4" name="Slide Number Placeholder 3"/>
+          <p:cNvSpPr>
+            <a:spLocks noGrp="1"/>
+          </p:cNvSpPr>
+          <p:nvPr>
+            <p:ph type="sldNum" idx="5"/>
+          </p:nvPr>
+        </p:nvSpPr>
+        <p:spPr/>
+        <p:txBody>
+          <a:bodyPr/>
+          <a:lstStyle/>
+          <a:p>
+            <a:endParaRPr/>
+          </a:p>
+        </p:txBody>
+      </p:sp>
+    </p:spTree>
+  </p:cSld>
+  <p:clrMapOvr>
+    <a:masterClrMapping/>
+  </p:clrMapOvr>
+</p:notes>
+</file>
+
 <file path=ppt/slideLayouts/slideLayout1.xml><?xml version="1.0" encoding="utf-8"?>
 <p:sldLayout xmlns:a="http://schemas.openxmlformats.org/drawingml/2006/main" xmlns:r="http://schemas.openxmlformats.org/officeDocument/2006/relationships" xmlns:p="http://schemas.openxmlformats.org/presentationml/2006/main" type="title" preserve="1">
   <p:cSld name="Title Slide">
@@ -908,7 +1032,7 @@
           <a:p>
             <a:fld id="{12D417FB-DB75-4510-8AD7-5416595AADD8}" type="datetime1">
               <a:rPr lang="en-US" smtClean="0"/>
-              <a:t>2026-08-18</a:t>
+              <a:t>2026-09-08</a:t>
             </a:fld>
             <a:endParaRPr lang="en-US"/>
           </a:p>
@@ -3276,7 +3400,7 @@
           <a:p>
             <a:fld id="{EC448E59-F64F-416B-85C7-F58EA54BAF31}" type="datetime1">
               <a:rPr lang="nl-BE" smtClean="0"/>
-              <a:t>18/08/2026</a:t>
+              <a:t>8/09/2026</a:t>
             </a:fld>
             <a:endParaRPr lang="nl-BE"/>
           </a:p>
@@ -3522,7 +3646,7 @@
           <a:p>
             <a:fld id="{9ED5C3B5-60AD-4494-9CFA-8B02B158E887}" type="datetime1">
               <a:rPr lang="nl-BE" smtClean="0"/>
-              <a:t>18/08/2026</a:t>
+              <a:t>8/09/2026</a:t>
             </a:fld>
             <a:endParaRPr lang="nl-BE"/>
           </a:p>
@@ -3640,7 +3764,7 @@
           <a:p>
             <a:fld id="{1E4894A8-27B8-4F4D-B345-90FD4A1447E9}" type="datetime1">
               <a:rPr lang="nl-BE" smtClean="0"/>
-              <a:t>18/08/2026</a:t>
+              <a:t>8/09/2026</a:t>
             </a:fld>
             <a:endParaRPr lang="nl-BE"/>
           </a:p>
@@ -3928,7 +4052,7 @@
           <a:p>
             <a:fld id="{44F0EF99-E673-4972-A23A-EB3FD1F7D254}" type="datetime1">
               <a:rPr lang="nl-BE" smtClean="0"/>
-              <a:t>18/08/2026</a:t>
+              <a:t>8/09/2026</a:t>
             </a:fld>
             <a:endParaRPr lang="nl-BE"/>
           </a:p>
@@ -41749,6 +41873,1260 @@
       </p:grpSpPr>
       <p:sp>
         <p:nvSpPr>
+          <p:cNvPr id="6" name="Title 5">
+            <a:extLst>
+              <a:ext uri="{FF2B5EF4-FFF2-40B4-BE49-F238E27FC236}">
+                <a16:creationId xmlns:a16="http://schemas.microsoft.com/office/drawing/2014/main" id="{F7226757-A157-4520-840A-53DD3580B2A7}"/>
+              </a:ext>
+            </a:extLst>
+          </p:cNvPr>
+          <p:cNvSpPr>
+            <a:spLocks noGrp="1"/>
+          </p:cNvSpPr>
+          <p:nvPr>
+            <p:ph type="title"/>
+          </p:nvPr>
+        </p:nvSpPr>
+        <p:spPr/>
+        <p:txBody>
+          <a:bodyPr/>
+          <a:lstStyle/>
+          <a:p>
+            <a:r>
+              <a:t>Let the research question choose the abstraction</a:t>
+            </a:r>
+          </a:p>
+        </p:txBody>
+      </p:sp>
+      <p:sp>
+        <p:nvSpPr>
+          <p:cNvPr id="5" name="Slide Number Placeholder 4">
+            <a:extLst>
+              <a:ext uri="{FF2B5EF4-FFF2-40B4-BE49-F238E27FC236}">
+                <a16:creationId xmlns:a16="http://schemas.microsoft.com/office/drawing/2014/main" id="{00867ADA-E149-4C7D-B537-856914DE63EE}"/>
+              </a:ext>
+            </a:extLst>
+          </p:cNvPr>
+          <p:cNvSpPr>
+            <a:spLocks noGrp="1"/>
+          </p:cNvSpPr>
+          <p:nvPr>
+            <p:ph type="sldNum" idx="12"/>
+          </p:nvPr>
+        </p:nvSpPr>
+        <p:spPr/>
+        <p:txBody>
+          <a:bodyPr/>
+          <a:lstStyle/>
+          <a:p>
+            <a:fld id="{DD1765E2-0FAE-40A2-8328-EFA0E6A1A332}" type="slidenum">
+              <a:rPr/>
+              <a:t>57</a:t>
+            </a:fld>
+            <a:endParaRPr/>
+          </a:p>
+        </p:txBody>
+      </p:sp>
+      <p:sp>
+        <p:nvSpPr>
+          <p:cNvPr id="7" name="Rectangle 6">
+            <a:extLst>
+              <a:ext uri="{FF2B5EF4-FFF2-40B4-BE49-F238E27FC236}">
+                <a16:creationId xmlns:a16="http://schemas.microsoft.com/office/drawing/2014/main" id="{99732596-37BB-4BCA-AA7A-15C4FA048D0B}"/>
+              </a:ext>
+            </a:extLst>
+          </p:cNvPr>
+          <p:cNvSpPr>
+            <a:spLocks noGrp="1"/>
+          </p:cNvSpPr>
+          <p:nvPr/>
+        </p:nvSpPr>
+        <p:spPr>
+          <a:xfrm>
+            <a:off x="685800" y="1871201"/>
+            <a:ext cx="2857500" cy="3020961"/>
+          </a:xfrm>
+          <a:prstGeom prst="rect">
+            <a:avLst/>
+          </a:prstGeom>
+          <a:solidFill>
+            <a:srgbClr val="F6E5DB"/>
+          </a:solidFill>
+          <a:ln w="0">
+            <a:solidFill>
+              <a:srgbClr val="F6E5DB"/>
+            </a:solidFill>
+            <a:prstDash val="solid"/>
+          </a:ln>
+        </p:spPr>
+        <p:txBody>
+          <a:bodyPr lIns="133350" tIns="76200" rIns="133350" bIns="76200" anchor="ctr"/>
+          <a:lstStyle/>
+          <a:p>
+            <a:endParaRPr/>
+          </a:p>
+        </p:txBody>
+      </p:sp>
+      <p:sp>
+        <p:nvSpPr>
+          <p:cNvPr id="8" name="Rectangle 7">
+            <a:extLst>
+              <a:ext uri="{FF2B5EF4-FFF2-40B4-BE49-F238E27FC236}">
+                <a16:creationId xmlns:a16="http://schemas.microsoft.com/office/drawing/2014/main" id="{CD5067C6-1EE0-4DCB-A950-9D6F6F8568E1}"/>
+              </a:ext>
+            </a:extLst>
+          </p:cNvPr>
+          <p:cNvSpPr>
+            <a:spLocks noGrp="1"/>
+          </p:cNvSpPr>
+          <p:nvPr/>
+        </p:nvSpPr>
+        <p:spPr>
+          <a:xfrm>
+            <a:off x="914400" y="2061702"/>
+            <a:ext cx="1524000" cy="304800"/>
+          </a:xfrm>
+          <a:prstGeom prst="rect">
+            <a:avLst/>
+          </a:prstGeom>
+          <a:noFill/>
+          <a:ln w="0">
+            <a:noFill/>
+            <a:prstDash val="solid"/>
+          </a:ln>
+        </p:spPr>
+        <p:txBody>
+          <a:bodyPr lIns="0" tIns="0" rIns="0" bIns="0" anchor="ctr"/>
+          <a:lstStyle/>
+          <a:p>
+            <a:pPr algn="l">
+              <a:buNone/>
+              <a:defRPr sz="1600" b="1">
+                <a:solidFill>
+                  <a:srgbClr val="DB6C30"/>
+                </a:solidFill>
+                <a:latin typeface="FlandersArtSans-Bold"/>
+                <a:ea typeface="FlandersArtSans-Bold"/>
+                <a:cs typeface="FlandersArtSans-Bold"/>
+              </a:defRPr>
+            </a:pPr>
+            <a:r>
+              <a:rPr sz="1600" b="1">
+                <a:solidFill>
+                  <a:srgbClr val="DB6C30"/>
+                </a:solidFill>
+                <a:latin typeface="FlandersArtSans-Bold"/>
+                <a:ea typeface="FlandersArtSans-Bold"/>
+                <a:cs typeface="FlandersArtSans-Bold"/>
+              </a:rPr>
+              <a:t>DECISION TEST</a:t>
+            </a:r>
+          </a:p>
+        </p:txBody>
+      </p:sp>
+      <p:sp>
+        <p:nvSpPr>
+          <p:cNvPr id="9" name="Rectangle 8">
+            <a:extLst>
+              <a:ext uri="{FF2B5EF4-FFF2-40B4-BE49-F238E27FC236}">
+                <a16:creationId xmlns:a16="http://schemas.microsoft.com/office/drawing/2014/main" id="{895EA5E8-64C6-4F60-9104-C991D0976623}"/>
+              </a:ext>
+            </a:extLst>
+          </p:cNvPr>
+          <p:cNvSpPr>
+            <a:spLocks noGrp="1"/>
+          </p:cNvSpPr>
+          <p:nvPr/>
+        </p:nvSpPr>
+        <p:spPr>
+          <a:xfrm>
+            <a:off x="914400" y="2395076"/>
+            <a:ext cx="2381250" cy="1505863"/>
+          </a:xfrm>
+          <a:prstGeom prst="rect">
+            <a:avLst/>
+          </a:prstGeom>
+          <a:noFill/>
+          <a:ln w="0">
+            <a:noFill/>
+            <a:prstDash val="solid"/>
+          </a:ln>
+        </p:spPr>
+        <p:txBody>
+          <a:bodyPr lIns="0" tIns="19050" rIns="0" bIns="19050" anchor="ctr"/>
+          <a:lstStyle/>
+          <a:p>
+            <a:pPr>
+              <a:defRPr sz="2000" b="1">
+                <a:solidFill>
+                  <a:srgbClr val="333639"/>
+                </a:solidFill>
+                <a:latin typeface="FlandersArtSans-Bold"/>
+                <a:ea typeface="FlandersArtSans-Bold"/>
+                <a:cs typeface="FlandersArtSans-Bold"/>
+              </a:defRPr>
+            </a:pPr>
+            <a:r>
+              <a:rPr sz="2000" dirty="0">
+                <a:solidFill>
+                  <a:srgbClr val="333639"/>
+                </a:solidFill>
+                <a:latin typeface="+mj-lt"/>
+                <a:ea typeface="FlandersArtSans-Bold"/>
+                <a:cs typeface="FlandersArtSans-Bold"/>
+              </a:rPr>
+              <a:t>Could another correct Trainer</a:t>
+            </a:r>
+            <a:r>
+              <a:rPr lang="en-US" sz="2000" dirty="0">
+                <a:solidFill>
+                  <a:srgbClr val="333639"/>
+                </a:solidFill>
+                <a:latin typeface="+mj-lt"/>
+                <a:ea typeface="FlandersArtSans-Bold"/>
+                <a:cs typeface="FlandersArtSans-Bold"/>
+              </a:rPr>
+              <a:t> </a:t>
+            </a:r>
+            <a:r>
+              <a:rPr lang="en-US" sz="2000" dirty="0">
+                <a:solidFill>
+                  <a:srgbClr val="333639"/>
+                </a:solidFill>
+                <a:latin typeface="+mj-lt"/>
+                <a:ea typeface="FlandersArtSans-Regular"/>
+                <a:cs typeface="FlandersArtSans-Regular"/>
+              </a:rPr>
+              <a:t>replace it without changing the scientific question?</a:t>
+            </a:r>
+            <a:endParaRPr sz="2000" dirty="0">
+              <a:solidFill>
+                <a:srgbClr val="333639"/>
+              </a:solidFill>
+              <a:latin typeface="+mj-lt"/>
+              <a:ea typeface="FlandersArtSans-Bold"/>
+              <a:cs typeface="FlandersArtSans-Bold"/>
+            </a:endParaRPr>
+          </a:p>
+        </p:txBody>
+      </p:sp>
+      <p:sp>
+        <p:nvSpPr>
+          <p:cNvPr id="10" name="Rectangle 9">
+            <a:extLst>
+              <a:ext uri="{FF2B5EF4-FFF2-40B4-BE49-F238E27FC236}">
+                <a16:creationId xmlns:a16="http://schemas.microsoft.com/office/drawing/2014/main" id="{D8023EE9-F105-4FBD-A3E6-D347E4476835}"/>
+              </a:ext>
+            </a:extLst>
+          </p:cNvPr>
+          <p:cNvSpPr>
+            <a:spLocks noGrp="1"/>
+          </p:cNvSpPr>
+          <p:nvPr/>
+        </p:nvSpPr>
+        <p:spPr>
+          <a:xfrm>
+            <a:off x="914400" y="4030411"/>
+            <a:ext cx="2381250" cy="916116"/>
+          </a:xfrm>
+          <a:prstGeom prst="rect">
+            <a:avLst/>
+          </a:prstGeom>
+          <a:noFill/>
+          <a:ln w="0">
+            <a:noFill/>
+            <a:prstDash val="solid"/>
+          </a:ln>
+        </p:spPr>
+        <p:txBody>
+          <a:bodyPr lIns="0" tIns="19050" rIns="0" bIns="19050" anchor="t"/>
+          <a:lstStyle/>
+          <a:p>
+            <a:pPr algn="l">
+              <a:buNone/>
+              <a:defRPr sz="1600" b="0">
+                <a:solidFill>
+                  <a:srgbClr val="333639"/>
+                </a:solidFill>
+                <a:latin typeface="FlandersArtSans-Regular"/>
+                <a:ea typeface="FlandersArtSans-Regular"/>
+                <a:cs typeface="FlandersArtSans-Regular"/>
+              </a:defRPr>
+            </a:pPr>
+            <a:r>
+              <a:rPr sz="1600" b="0" dirty="0">
+                <a:solidFill>
+                  <a:srgbClr val="333639"/>
+                </a:solidFill>
+                <a:latin typeface="FlandersArtSans-Regular"/>
+                <a:ea typeface="FlandersArtSans-Regular"/>
+                <a:cs typeface="FlandersArtSans-Regular"/>
+              </a:rPr>
+              <a:t>YES  →  Lightning</a:t>
+            </a:r>
+          </a:p>
+          <a:p>
+            <a:pPr algn="l">
+              <a:buNone/>
+              <a:defRPr sz="1600" b="0">
+                <a:solidFill>
+                  <a:srgbClr val="333639"/>
+                </a:solidFill>
+                <a:latin typeface="FlandersArtSans-Regular"/>
+                <a:ea typeface="FlandersArtSans-Regular"/>
+                <a:cs typeface="FlandersArtSans-Regular"/>
+              </a:defRPr>
+            </a:pPr>
+            <a:r>
+              <a:rPr sz="1600" b="0" dirty="0">
+                <a:solidFill>
+                  <a:srgbClr val="333639"/>
+                </a:solidFill>
+                <a:latin typeface="FlandersArtSans-Regular"/>
+                <a:ea typeface="FlandersArtSans-Regular"/>
+                <a:cs typeface="FlandersArtSans-Regular"/>
+              </a:rPr>
+              <a:t>PARTLY  →  Fabric</a:t>
+            </a:r>
+          </a:p>
+          <a:p>
+            <a:pPr algn="l">
+              <a:buNone/>
+              <a:defRPr sz="1600" b="0">
+                <a:solidFill>
+                  <a:srgbClr val="333639"/>
+                </a:solidFill>
+                <a:latin typeface="FlandersArtSans-Regular"/>
+                <a:ea typeface="FlandersArtSans-Regular"/>
+                <a:cs typeface="FlandersArtSans-Regular"/>
+              </a:defRPr>
+            </a:pPr>
+            <a:r>
+              <a:rPr sz="1600" b="0" dirty="0">
+                <a:solidFill>
+                  <a:srgbClr val="333639"/>
+                </a:solidFill>
+                <a:latin typeface="FlandersArtSans-Regular"/>
+                <a:ea typeface="FlandersArtSans-Regular"/>
+                <a:cs typeface="FlandersArtSans-Regular"/>
+              </a:rPr>
+              <a:t>NO  →  native </a:t>
+            </a:r>
+            <a:r>
+              <a:rPr sz="1600" b="0" dirty="0" err="1">
+                <a:solidFill>
+                  <a:srgbClr val="333639"/>
+                </a:solidFill>
+                <a:latin typeface="FlandersArtSans-Regular"/>
+                <a:ea typeface="FlandersArtSans-Regular"/>
+                <a:cs typeface="FlandersArtSans-Regular"/>
+              </a:rPr>
+              <a:t>PyTorch</a:t>
+            </a:r>
+            <a:endParaRPr sz="1600" b="0" dirty="0">
+              <a:solidFill>
+                <a:srgbClr val="333639"/>
+              </a:solidFill>
+              <a:latin typeface="FlandersArtSans-Regular"/>
+              <a:ea typeface="FlandersArtSans-Regular"/>
+              <a:cs typeface="FlandersArtSans-Regular"/>
+            </a:endParaRPr>
+          </a:p>
+        </p:txBody>
+      </p:sp>
+      <p:sp>
+        <p:nvSpPr>
+          <p:cNvPr id="11" name="Rectangle 10">
+            <a:extLst>
+              <a:ext uri="{FF2B5EF4-FFF2-40B4-BE49-F238E27FC236}">
+                <a16:creationId xmlns:a16="http://schemas.microsoft.com/office/drawing/2014/main" id="{8616CF2D-AB07-47DA-8570-3077CD50E820}"/>
+              </a:ext>
+            </a:extLst>
+          </p:cNvPr>
+          <p:cNvSpPr>
+            <a:spLocks noGrp="1"/>
+          </p:cNvSpPr>
+          <p:nvPr/>
+        </p:nvSpPr>
+        <p:spPr>
+          <a:xfrm>
+            <a:off x="4191000" y="1428750"/>
+            <a:ext cx="1714500" cy="304800"/>
+          </a:xfrm>
+          <a:prstGeom prst="rect">
+            <a:avLst/>
+          </a:prstGeom>
+          <a:noFill/>
+          <a:ln w="0">
+            <a:noFill/>
+            <a:prstDash val="solid"/>
+          </a:ln>
+        </p:spPr>
+        <p:txBody>
+          <a:bodyPr lIns="0" tIns="0" rIns="0" bIns="0" anchor="ctr"/>
+          <a:lstStyle/>
+          <a:p>
+            <a:pPr algn="l">
+              <a:buNone/>
+              <a:defRPr sz="1600" b="1">
+                <a:solidFill>
+                  <a:srgbClr val="DB6C30"/>
+                </a:solidFill>
+                <a:latin typeface="FlandersArtSans-Bold"/>
+                <a:ea typeface="FlandersArtSans-Bold"/>
+                <a:cs typeface="FlandersArtSans-Bold"/>
+              </a:defRPr>
+            </a:pPr>
+            <a:r>
+              <a:rPr sz="1600" b="1">
+                <a:solidFill>
+                  <a:srgbClr val="DB6C30"/>
+                </a:solidFill>
+                <a:latin typeface="FlandersArtSans-Bold"/>
+                <a:ea typeface="FlandersArtSans-Bold"/>
+                <a:cs typeface="FlandersArtSans-Bold"/>
+              </a:rPr>
+              <a:t>CHOICE</a:t>
+            </a:r>
+          </a:p>
+        </p:txBody>
+      </p:sp>
+      <p:sp>
+        <p:nvSpPr>
+          <p:cNvPr id="12" name="Rectangle 11">
+            <a:extLst>
+              <a:ext uri="{FF2B5EF4-FFF2-40B4-BE49-F238E27FC236}">
+                <a16:creationId xmlns:a16="http://schemas.microsoft.com/office/drawing/2014/main" id="{E2C8AE6B-CC04-477D-BAAD-6CDF5C53B122}"/>
+              </a:ext>
+            </a:extLst>
+          </p:cNvPr>
+          <p:cNvSpPr>
+            <a:spLocks noGrp="1"/>
+          </p:cNvSpPr>
+          <p:nvPr/>
+        </p:nvSpPr>
+        <p:spPr>
+          <a:xfrm>
+            <a:off x="4191000" y="1809750"/>
+            <a:ext cx="400050" cy="400050"/>
+          </a:xfrm>
+          <a:prstGeom prst="rect">
+            <a:avLst/>
+          </a:prstGeom>
+          <a:noFill/>
+          <a:ln w="0">
+            <a:noFill/>
+            <a:prstDash val="solid"/>
+          </a:ln>
+        </p:spPr>
+        <p:txBody>
+          <a:bodyPr lIns="0" tIns="19050" rIns="0" bIns="19050" anchor="ctr"/>
+          <a:lstStyle/>
+          <a:p>
+            <a:pPr algn="ctr">
+              <a:buNone/>
+              <a:defRPr sz="2600" b="1">
+                <a:solidFill>
+                  <a:srgbClr val="DB6C30"/>
+                </a:solidFill>
+                <a:latin typeface="FlandersArtSans-Bold"/>
+                <a:ea typeface="FlandersArtSans-Bold"/>
+                <a:cs typeface="FlandersArtSans-Bold"/>
+              </a:defRPr>
+            </a:pPr>
+            <a:r>
+              <a:rPr sz="2600" b="1">
+                <a:solidFill>
+                  <a:srgbClr val="DB6C30"/>
+                </a:solidFill>
+                <a:latin typeface="FlandersArtSans-Bold"/>
+                <a:ea typeface="FlandersArtSans-Bold"/>
+                <a:cs typeface="FlandersArtSans-Bold"/>
+              </a:rPr>
+              <a:t>1</a:t>
+            </a:r>
+          </a:p>
+        </p:txBody>
+      </p:sp>
+      <p:sp>
+        <p:nvSpPr>
+          <p:cNvPr id="13" name="Rectangle 12">
+            <a:extLst>
+              <a:ext uri="{FF2B5EF4-FFF2-40B4-BE49-F238E27FC236}">
+                <a16:creationId xmlns:a16="http://schemas.microsoft.com/office/drawing/2014/main" id="{F3C678B8-8A8A-4DE3-B596-96C97B6F289F}"/>
+              </a:ext>
+            </a:extLst>
+          </p:cNvPr>
+          <p:cNvSpPr>
+            <a:spLocks noGrp="1"/>
+          </p:cNvSpPr>
+          <p:nvPr/>
+        </p:nvSpPr>
+        <p:spPr>
+          <a:xfrm>
+            <a:off x="4781550" y="1790700"/>
+            <a:ext cx="6172200" cy="285750"/>
+          </a:xfrm>
+          <a:prstGeom prst="rect">
+            <a:avLst/>
+          </a:prstGeom>
+          <a:noFill/>
+          <a:ln w="0">
+            <a:noFill/>
+            <a:prstDash val="solid"/>
+          </a:ln>
+        </p:spPr>
+        <p:txBody>
+          <a:bodyPr lIns="0" tIns="19050" rIns="0" bIns="19050" anchor="ctr"/>
+          <a:lstStyle/>
+          <a:p>
+            <a:pPr algn="l">
+              <a:buNone/>
+              <a:defRPr sz="1800" b="1">
+                <a:solidFill>
+                  <a:srgbClr val="333639"/>
+                </a:solidFill>
+                <a:latin typeface="FlandersArtSans-Bold"/>
+                <a:ea typeface="FlandersArtSans-Bold"/>
+                <a:cs typeface="FlandersArtSans-Bold"/>
+              </a:defRPr>
+            </a:pPr>
+            <a:r>
+              <a:rPr sz="1800" b="1">
+                <a:solidFill>
+                  <a:srgbClr val="333639"/>
+                </a:solidFill>
+                <a:latin typeface="FlandersArtSans-Bold"/>
+                <a:ea typeface="FlandersArtSans-Bold"/>
+                <a:cs typeface="FlandersArtSans-Bold"/>
+              </a:rPr>
+              <a:t>Training loop is infrastructure</a:t>
+            </a:r>
+          </a:p>
+        </p:txBody>
+      </p:sp>
+      <p:sp>
+        <p:nvSpPr>
+          <p:cNvPr id="14" name="Rectangle 13">
+            <a:extLst>
+              <a:ext uri="{FF2B5EF4-FFF2-40B4-BE49-F238E27FC236}">
+                <a16:creationId xmlns:a16="http://schemas.microsoft.com/office/drawing/2014/main" id="{2684D7C4-A9BC-462E-92E4-3095B0CE6513}"/>
+              </a:ext>
+            </a:extLst>
+          </p:cNvPr>
+          <p:cNvSpPr>
+            <a:spLocks noGrp="1"/>
+          </p:cNvSpPr>
+          <p:nvPr/>
+        </p:nvSpPr>
+        <p:spPr>
+          <a:xfrm>
+            <a:off x="4781550" y="2066925"/>
+            <a:ext cx="6172200" cy="400050"/>
+          </a:xfrm>
+          <a:prstGeom prst="rect">
+            <a:avLst/>
+          </a:prstGeom>
+          <a:noFill/>
+          <a:ln w="0">
+            <a:noFill/>
+            <a:prstDash val="solid"/>
+          </a:ln>
+        </p:spPr>
+        <p:txBody>
+          <a:bodyPr lIns="0" tIns="19050" rIns="0" bIns="19050" anchor="t"/>
+          <a:lstStyle/>
+          <a:p>
+            <a:pPr algn="l">
+              <a:buNone/>
+              <a:defRPr sz="1600" b="0">
+                <a:solidFill>
+                  <a:srgbClr val="68717C"/>
+                </a:solidFill>
+                <a:latin typeface="FlandersArtSans-Regular"/>
+                <a:ea typeface="FlandersArtSans-Regular"/>
+                <a:cs typeface="FlandersArtSans-Regular"/>
+              </a:defRPr>
+            </a:pPr>
+            <a:r>
+              <a:rPr sz="1600" b="0">
+                <a:solidFill>
+                  <a:srgbClr val="68717C"/>
+                </a:solidFill>
+                <a:latin typeface="FlandersArtSans-Regular"/>
+                <a:ea typeface="FlandersArtSans-Regular"/>
+                <a:cs typeface="FlandersArtSans-Regular"/>
+              </a:rPr>
+              <a:t>Use PyTorch Lightning: standard loop, DDP, logging and checkpoints.</a:t>
+            </a:r>
+          </a:p>
+        </p:txBody>
+      </p:sp>
+      <p:sp>
+        <p:nvSpPr>
+          <p:cNvPr id="15" name="Rectangle 14">
+            <a:extLst>
+              <a:ext uri="{FF2B5EF4-FFF2-40B4-BE49-F238E27FC236}">
+                <a16:creationId xmlns:a16="http://schemas.microsoft.com/office/drawing/2014/main" id="{DA00923C-2290-4115-AD8B-1DA1942EF370}"/>
+              </a:ext>
+            </a:extLst>
+          </p:cNvPr>
+          <p:cNvSpPr>
+            <a:spLocks noGrp="1"/>
+          </p:cNvSpPr>
+          <p:nvPr/>
+        </p:nvSpPr>
+        <p:spPr>
+          <a:xfrm>
+            <a:off x="4781550" y="2590800"/>
+            <a:ext cx="6191250" cy="9525"/>
+          </a:xfrm>
+          <a:prstGeom prst="rect">
+            <a:avLst/>
+          </a:prstGeom>
+          <a:solidFill>
+            <a:srgbClr val="C7CBD2"/>
+          </a:solidFill>
+          <a:ln w="0">
+            <a:solidFill>
+              <a:srgbClr val="C7CBD2"/>
+            </a:solidFill>
+            <a:prstDash val="solid"/>
+          </a:ln>
+        </p:spPr>
+        <p:txBody>
+          <a:bodyPr/>
+          <a:lstStyle/>
+          <a:p>
+            <a:endParaRPr/>
+          </a:p>
+        </p:txBody>
+      </p:sp>
+      <p:sp>
+        <p:nvSpPr>
+          <p:cNvPr id="16" name="Rectangle 15">
+            <a:extLst>
+              <a:ext uri="{FF2B5EF4-FFF2-40B4-BE49-F238E27FC236}">
+                <a16:creationId xmlns:a16="http://schemas.microsoft.com/office/drawing/2014/main" id="{C9652C2B-C1C6-464E-8706-E695E33E22A4}"/>
+              </a:ext>
+            </a:extLst>
+          </p:cNvPr>
+          <p:cNvSpPr>
+            <a:spLocks noGrp="1"/>
+          </p:cNvSpPr>
+          <p:nvPr/>
+        </p:nvSpPr>
+        <p:spPr>
+          <a:xfrm>
+            <a:off x="4191000" y="2800350"/>
+            <a:ext cx="400050" cy="400050"/>
+          </a:xfrm>
+          <a:prstGeom prst="rect">
+            <a:avLst/>
+          </a:prstGeom>
+          <a:noFill/>
+          <a:ln w="0">
+            <a:noFill/>
+            <a:prstDash val="solid"/>
+          </a:ln>
+        </p:spPr>
+        <p:txBody>
+          <a:bodyPr lIns="0" tIns="19050" rIns="0" bIns="19050" anchor="ctr"/>
+          <a:lstStyle/>
+          <a:p>
+            <a:pPr algn="ctr">
+              <a:buNone/>
+              <a:defRPr sz="2600" b="1">
+                <a:solidFill>
+                  <a:srgbClr val="DB6C30"/>
+                </a:solidFill>
+                <a:latin typeface="FlandersArtSans-Bold"/>
+                <a:ea typeface="FlandersArtSans-Bold"/>
+                <a:cs typeface="FlandersArtSans-Bold"/>
+              </a:defRPr>
+            </a:pPr>
+            <a:r>
+              <a:rPr sz="2600" b="1">
+                <a:solidFill>
+                  <a:srgbClr val="DB6C30"/>
+                </a:solidFill>
+                <a:latin typeface="FlandersArtSans-Bold"/>
+                <a:ea typeface="FlandersArtSans-Bold"/>
+                <a:cs typeface="FlandersArtSans-Bold"/>
+              </a:rPr>
+              <a:t>2</a:t>
+            </a:r>
+          </a:p>
+        </p:txBody>
+      </p:sp>
+      <p:sp>
+        <p:nvSpPr>
+          <p:cNvPr id="17" name="Rectangle 16">
+            <a:extLst>
+              <a:ext uri="{FF2B5EF4-FFF2-40B4-BE49-F238E27FC236}">
+                <a16:creationId xmlns:a16="http://schemas.microsoft.com/office/drawing/2014/main" id="{463FE799-703A-4C3E-9D06-072886EE2EB4}"/>
+              </a:ext>
+            </a:extLst>
+          </p:cNvPr>
+          <p:cNvSpPr>
+            <a:spLocks noGrp="1"/>
+          </p:cNvSpPr>
+          <p:nvPr/>
+        </p:nvSpPr>
+        <p:spPr>
+          <a:xfrm>
+            <a:off x="4781550" y="2781300"/>
+            <a:ext cx="6172200" cy="285750"/>
+          </a:xfrm>
+          <a:prstGeom prst="rect">
+            <a:avLst/>
+          </a:prstGeom>
+          <a:noFill/>
+          <a:ln w="0">
+            <a:noFill/>
+            <a:prstDash val="solid"/>
+          </a:ln>
+        </p:spPr>
+        <p:txBody>
+          <a:bodyPr lIns="0" tIns="19050" rIns="0" bIns="19050" anchor="ctr"/>
+          <a:lstStyle/>
+          <a:p>
+            <a:pPr algn="l">
+              <a:buNone/>
+              <a:defRPr sz="1800" b="1">
+                <a:solidFill>
+                  <a:srgbClr val="333639"/>
+                </a:solidFill>
+                <a:latin typeface="FlandersArtSans-Bold"/>
+                <a:ea typeface="FlandersArtSans-Bold"/>
+                <a:cs typeface="FlandersArtSans-Bold"/>
+              </a:defRPr>
+            </a:pPr>
+            <a:r>
+              <a:rPr sz="1800" b="1">
+                <a:solidFill>
+                  <a:srgbClr val="333639"/>
+                </a:solidFill>
+                <a:latin typeface="FlandersArtSans-Bold"/>
+                <a:ea typeface="FlandersArtSans-Bold"/>
+                <a:cs typeface="FlandersArtSans-Bold"/>
+              </a:rPr>
+              <a:t>Need explicit loop control</a:t>
+            </a:r>
+          </a:p>
+        </p:txBody>
+      </p:sp>
+      <p:sp>
+        <p:nvSpPr>
+          <p:cNvPr id="18" name="Rectangle 17">
+            <a:extLst>
+              <a:ext uri="{FF2B5EF4-FFF2-40B4-BE49-F238E27FC236}">
+                <a16:creationId xmlns:a16="http://schemas.microsoft.com/office/drawing/2014/main" id="{2D1C3664-A851-4899-B0B8-DA445B2A4197}"/>
+              </a:ext>
+            </a:extLst>
+          </p:cNvPr>
+          <p:cNvSpPr>
+            <a:spLocks noGrp="1"/>
+          </p:cNvSpPr>
+          <p:nvPr/>
+        </p:nvSpPr>
+        <p:spPr>
+          <a:xfrm>
+            <a:off x="4781550" y="3057525"/>
+            <a:ext cx="6172200" cy="400050"/>
+          </a:xfrm>
+          <a:prstGeom prst="rect">
+            <a:avLst/>
+          </a:prstGeom>
+          <a:noFill/>
+          <a:ln w="0">
+            <a:noFill/>
+            <a:prstDash val="solid"/>
+          </a:ln>
+        </p:spPr>
+        <p:txBody>
+          <a:bodyPr lIns="0" tIns="19050" rIns="0" bIns="19050" anchor="t"/>
+          <a:lstStyle/>
+          <a:p>
+            <a:pPr algn="l">
+              <a:buNone/>
+              <a:defRPr sz="1600" b="0">
+                <a:solidFill>
+                  <a:srgbClr val="68717C"/>
+                </a:solidFill>
+                <a:latin typeface="FlandersArtSans-Regular"/>
+                <a:ea typeface="FlandersArtSans-Regular"/>
+                <a:cs typeface="FlandersArtSans-Regular"/>
+              </a:defRPr>
+            </a:pPr>
+            <a:r>
+              <a:rPr sz="1600" b="0">
+                <a:solidFill>
+                  <a:srgbClr val="68717C"/>
+                </a:solidFill>
+                <a:latin typeface="FlandersArtSans-Regular"/>
+                <a:ea typeface="FlandersArtSans-Regular"/>
+                <a:cs typeface="FlandersArtSans-Regular"/>
+              </a:rPr>
+              <a:t>Use Lightning Fabric: keep iteration, backward and optimizer logic visible.</a:t>
+            </a:r>
+          </a:p>
+        </p:txBody>
+      </p:sp>
+      <p:sp>
+        <p:nvSpPr>
+          <p:cNvPr id="19" name="Rectangle 18">
+            <a:extLst>
+              <a:ext uri="{FF2B5EF4-FFF2-40B4-BE49-F238E27FC236}">
+                <a16:creationId xmlns:a16="http://schemas.microsoft.com/office/drawing/2014/main" id="{2ED507F6-38CA-49F5-AB85-76146F3B9019}"/>
+              </a:ext>
+            </a:extLst>
+          </p:cNvPr>
+          <p:cNvSpPr>
+            <a:spLocks noGrp="1"/>
+          </p:cNvSpPr>
+          <p:nvPr/>
+        </p:nvSpPr>
+        <p:spPr>
+          <a:xfrm>
+            <a:off x="4781550" y="3657600"/>
+            <a:ext cx="6191250" cy="9525"/>
+          </a:xfrm>
+          <a:prstGeom prst="rect">
+            <a:avLst/>
+          </a:prstGeom>
+          <a:solidFill>
+            <a:srgbClr val="C7CBD2"/>
+          </a:solidFill>
+          <a:ln w="0">
+            <a:solidFill>
+              <a:srgbClr val="C7CBD2"/>
+            </a:solidFill>
+            <a:prstDash val="solid"/>
+          </a:ln>
+        </p:spPr>
+        <p:txBody>
+          <a:bodyPr/>
+          <a:lstStyle/>
+          <a:p>
+            <a:endParaRPr/>
+          </a:p>
+        </p:txBody>
+      </p:sp>
+      <p:sp>
+        <p:nvSpPr>
+          <p:cNvPr id="20" name="Rectangle 19">
+            <a:extLst>
+              <a:ext uri="{FF2B5EF4-FFF2-40B4-BE49-F238E27FC236}">
+                <a16:creationId xmlns:a16="http://schemas.microsoft.com/office/drawing/2014/main" id="{7CD192CD-95C5-4EF5-B6BA-B6FFCDEB22DC}"/>
+              </a:ext>
+            </a:extLst>
+          </p:cNvPr>
+          <p:cNvSpPr>
+            <a:spLocks noGrp="1"/>
+          </p:cNvSpPr>
+          <p:nvPr/>
+        </p:nvSpPr>
+        <p:spPr>
+          <a:xfrm>
+            <a:off x="4191000" y="3867150"/>
+            <a:ext cx="400050" cy="400050"/>
+          </a:xfrm>
+          <a:prstGeom prst="rect">
+            <a:avLst/>
+          </a:prstGeom>
+          <a:noFill/>
+          <a:ln w="0">
+            <a:noFill/>
+            <a:prstDash val="solid"/>
+          </a:ln>
+        </p:spPr>
+        <p:txBody>
+          <a:bodyPr lIns="0" tIns="19050" rIns="0" bIns="19050" anchor="ctr"/>
+          <a:lstStyle/>
+          <a:p>
+            <a:pPr algn="ctr">
+              <a:buNone/>
+              <a:defRPr sz="2600" b="1">
+                <a:solidFill>
+                  <a:srgbClr val="DB6C30"/>
+                </a:solidFill>
+                <a:latin typeface="FlandersArtSans-Bold"/>
+                <a:ea typeface="FlandersArtSans-Bold"/>
+                <a:cs typeface="FlandersArtSans-Bold"/>
+              </a:defRPr>
+            </a:pPr>
+            <a:r>
+              <a:rPr sz="2600" b="1">
+                <a:solidFill>
+                  <a:srgbClr val="DB6C30"/>
+                </a:solidFill>
+                <a:latin typeface="FlandersArtSans-Bold"/>
+                <a:ea typeface="FlandersArtSans-Bold"/>
+                <a:cs typeface="FlandersArtSans-Bold"/>
+              </a:rPr>
+              <a:t>3</a:t>
+            </a:r>
+          </a:p>
+        </p:txBody>
+      </p:sp>
+      <p:sp>
+        <p:nvSpPr>
+          <p:cNvPr id="21" name="Rectangle 20">
+            <a:extLst>
+              <a:ext uri="{FF2B5EF4-FFF2-40B4-BE49-F238E27FC236}">
+                <a16:creationId xmlns:a16="http://schemas.microsoft.com/office/drawing/2014/main" id="{46EF116E-DA17-4619-915C-19C8160FA838}"/>
+              </a:ext>
+            </a:extLst>
+          </p:cNvPr>
+          <p:cNvSpPr>
+            <a:spLocks noGrp="1"/>
+          </p:cNvSpPr>
+          <p:nvPr/>
+        </p:nvSpPr>
+        <p:spPr>
+          <a:xfrm>
+            <a:off x="4781550" y="3848100"/>
+            <a:ext cx="6172200" cy="285750"/>
+          </a:xfrm>
+          <a:prstGeom prst="rect">
+            <a:avLst/>
+          </a:prstGeom>
+          <a:noFill/>
+          <a:ln w="0">
+            <a:noFill/>
+            <a:prstDash val="solid"/>
+          </a:ln>
+        </p:spPr>
+        <p:txBody>
+          <a:bodyPr lIns="0" tIns="19050" rIns="0" bIns="19050" anchor="ctr"/>
+          <a:lstStyle/>
+          <a:p>
+            <a:pPr algn="l">
+              <a:buNone/>
+              <a:defRPr sz="1800" b="1">
+                <a:solidFill>
+                  <a:srgbClr val="333639"/>
+                </a:solidFill>
+                <a:latin typeface="FlandersArtSans-Bold"/>
+                <a:ea typeface="FlandersArtSans-Bold"/>
+                <a:cs typeface="FlandersArtSans-Bold"/>
+              </a:defRPr>
+            </a:pPr>
+            <a:r>
+              <a:rPr sz="1800" b="1">
+                <a:solidFill>
+                  <a:srgbClr val="333639"/>
+                </a:solidFill>
+                <a:latin typeface="FlandersArtSans-Bold"/>
+                <a:ea typeface="FlandersArtSans-Bold"/>
+                <a:cs typeface="FlandersArtSans-Bold"/>
+              </a:rPr>
+              <a:t>Learning mechanics are the variable</a:t>
+            </a:r>
+          </a:p>
+        </p:txBody>
+      </p:sp>
+      <p:sp>
+        <p:nvSpPr>
+          <p:cNvPr id="22" name="Rectangle 21">
+            <a:extLst>
+              <a:ext uri="{FF2B5EF4-FFF2-40B4-BE49-F238E27FC236}">
+                <a16:creationId xmlns:a16="http://schemas.microsoft.com/office/drawing/2014/main" id="{B5229582-E9C5-424A-BE63-28FAE134F3CF}"/>
+              </a:ext>
+            </a:extLst>
+          </p:cNvPr>
+          <p:cNvSpPr>
+            <a:spLocks noGrp="1"/>
+          </p:cNvSpPr>
+          <p:nvPr/>
+        </p:nvSpPr>
+        <p:spPr>
+          <a:xfrm>
+            <a:off x="4781550" y="4124325"/>
+            <a:ext cx="6172200" cy="400050"/>
+          </a:xfrm>
+          <a:prstGeom prst="rect">
+            <a:avLst/>
+          </a:prstGeom>
+          <a:noFill/>
+          <a:ln w="0">
+            <a:noFill/>
+            <a:prstDash val="solid"/>
+          </a:ln>
+        </p:spPr>
+        <p:txBody>
+          <a:bodyPr lIns="0" tIns="19050" rIns="0" bIns="19050" anchor="t"/>
+          <a:lstStyle/>
+          <a:p>
+            <a:pPr algn="l">
+              <a:buNone/>
+              <a:defRPr sz="1600" b="0">
+                <a:solidFill>
+                  <a:srgbClr val="68717C"/>
+                </a:solidFill>
+                <a:latin typeface="FlandersArtSans-Regular"/>
+                <a:ea typeface="FlandersArtSans-Regular"/>
+                <a:cs typeface="FlandersArtSans-Regular"/>
+              </a:defRPr>
+            </a:pPr>
+            <a:r>
+              <a:rPr sz="1600" b="0">
+                <a:solidFill>
+                  <a:srgbClr val="68717C"/>
+                </a:solidFill>
+                <a:latin typeface="FlandersArtSans-Regular"/>
+                <a:ea typeface="FlandersArtSans-Regular"/>
+                <a:cs typeface="FlandersArtSans-Regular"/>
+              </a:rPr>
+              <a:t>Use native PyTorch: custom optimization, collectives or parallelism.</a:t>
+            </a:r>
+          </a:p>
+        </p:txBody>
+      </p:sp>
+      <p:sp>
+        <p:nvSpPr>
+          <p:cNvPr id="23" name="Rectangle 22">
+            <a:extLst>
+              <a:ext uri="{FF2B5EF4-FFF2-40B4-BE49-F238E27FC236}">
+                <a16:creationId xmlns:a16="http://schemas.microsoft.com/office/drawing/2014/main" id="{D1027F81-7512-4DD6-B897-47CE3ABD5FE1}"/>
+              </a:ext>
+            </a:extLst>
+          </p:cNvPr>
+          <p:cNvSpPr>
+            <a:spLocks noGrp="1"/>
+          </p:cNvSpPr>
+          <p:nvPr/>
+        </p:nvSpPr>
+        <p:spPr>
+          <a:xfrm>
+            <a:off x="4191000" y="4705350"/>
+            <a:ext cx="1238250" cy="304800"/>
+          </a:xfrm>
+          <a:prstGeom prst="rect">
+            <a:avLst/>
+          </a:prstGeom>
+          <a:noFill/>
+          <a:ln w="0">
+            <a:noFill/>
+            <a:prstDash val="solid"/>
+          </a:ln>
+        </p:spPr>
+        <p:txBody>
+          <a:bodyPr lIns="0" tIns="0" rIns="0" bIns="0" anchor="ctr"/>
+          <a:lstStyle/>
+          <a:p>
+            <a:pPr algn="l">
+              <a:buNone/>
+              <a:defRPr sz="1600" b="1">
+                <a:solidFill>
+                  <a:srgbClr val="68717C"/>
+                </a:solidFill>
+                <a:latin typeface="FlandersArtSans-Bold"/>
+                <a:ea typeface="FlandersArtSans-Bold"/>
+                <a:cs typeface="FlandersArtSans-Bold"/>
+              </a:defRPr>
+            </a:pPr>
+            <a:r>
+              <a:rPr sz="1600" b="1">
+                <a:solidFill>
+                  <a:srgbClr val="68717C"/>
+                </a:solidFill>
+                <a:latin typeface="FlandersArtSans-Bold"/>
+                <a:ea typeface="FlandersArtSans-Bold"/>
+                <a:cs typeface="FlandersArtSans-Bold"/>
+              </a:rPr>
+              <a:t>BAD PROXY</a:t>
+            </a:r>
+          </a:p>
+        </p:txBody>
+      </p:sp>
+      <p:sp>
+        <p:nvSpPr>
+          <p:cNvPr id="24" name="Rectangle 23">
+            <a:extLst>
+              <a:ext uri="{FF2B5EF4-FFF2-40B4-BE49-F238E27FC236}">
+                <a16:creationId xmlns:a16="http://schemas.microsoft.com/office/drawing/2014/main" id="{BF87CC4C-B627-4276-877B-4F919C69AA4E}"/>
+              </a:ext>
+            </a:extLst>
+          </p:cNvPr>
+          <p:cNvSpPr>
+            <a:spLocks noGrp="1"/>
+          </p:cNvSpPr>
+          <p:nvPr/>
+        </p:nvSpPr>
+        <p:spPr>
+          <a:xfrm>
+            <a:off x="4191000" y="4953000"/>
+            <a:ext cx="6858000" cy="285750"/>
+          </a:xfrm>
+          <a:prstGeom prst="rect">
+            <a:avLst/>
+          </a:prstGeom>
+          <a:noFill/>
+          <a:ln w="0">
+            <a:noFill/>
+            <a:prstDash val="solid"/>
+          </a:ln>
+        </p:spPr>
+        <p:txBody>
+          <a:bodyPr lIns="0" tIns="19050" rIns="0" bIns="19050" anchor="t"/>
+          <a:lstStyle/>
+          <a:p>
+            <a:pPr algn="l">
+              <a:buNone/>
+              <a:defRPr sz="1600" b="0">
+                <a:solidFill>
+                  <a:srgbClr val="68717C"/>
+                </a:solidFill>
+                <a:latin typeface="FlandersArtSans-Regular"/>
+                <a:ea typeface="FlandersArtSans-Regular"/>
+                <a:cs typeface="FlandersArtSans-Regular"/>
+              </a:defRPr>
+            </a:pPr>
+            <a:r>
+              <a:rPr sz="1600" b="0">
+                <a:solidFill>
+                  <a:srgbClr val="68717C"/>
+                </a:solidFill>
+                <a:latin typeface="FlandersArtSans-Regular"/>
+                <a:ea typeface="FlandersArtSans-Regular"/>
+                <a:cs typeface="FlandersArtSans-Regular"/>
+              </a:rPr>
+              <a:t>Discipline is a poor proxy: either field may need either path.</a:t>
+            </a:r>
+          </a:p>
+        </p:txBody>
+      </p:sp>
+      <p:sp>
+        <p:nvSpPr>
+          <p:cNvPr id="25" name="Rectangle 24">
+            <a:extLst>
+              <a:ext uri="{FF2B5EF4-FFF2-40B4-BE49-F238E27FC236}">
+                <a16:creationId xmlns:a16="http://schemas.microsoft.com/office/drawing/2014/main" id="{7CD2FF72-7688-491C-A2C1-73D14790F3DC}"/>
+              </a:ext>
+            </a:extLst>
+          </p:cNvPr>
+          <p:cNvSpPr>
+            <a:spLocks noGrp="1"/>
+          </p:cNvSpPr>
+          <p:nvPr/>
+        </p:nvSpPr>
+        <p:spPr>
+          <a:xfrm>
+            <a:off x="685800" y="5600700"/>
+            <a:ext cx="10744200" cy="28575"/>
+          </a:xfrm>
+          <a:prstGeom prst="rect">
+            <a:avLst/>
+          </a:prstGeom>
+          <a:solidFill>
+            <a:srgbClr val="DB6C30"/>
+          </a:solidFill>
+          <a:ln w="0">
+            <a:solidFill>
+              <a:srgbClr val="DB6C30"/>
+            </a:solidFill>
+            <a:prstDash val="solid"/>
+          </a:ln>
+        </p:spPr>
+        <p:txBody>
+          <a:bodyPr/>
+          <a:lstStyle/>
+          <a:p>
+            <a:endParaRPr/>
+          </a:p>
+        </p:txBody>
+      </p:sp>
+      <p:sp>
+        <p:nvSpPr>
+          <p:cNvPr id="26" name="Rectangle 25">
+            <a:extLst>
+              <a:ext uri="{FF2B5EF4-FFF2-40B4-BE49-F238E27FC236}">
+                <a16:creationId xmlns:a16="http://schemas.microsoft.com/office/drawing/2014/main" id="{8A06E059-4F60-4E77-8D64-96A399D0E359}"/>
+              </a:ext>
+            </a:extLst>
+          </p:cNvPr>
+          <p:cNvSpPr>
+            <a:spLocks noGrp="1"/>
+          </p:cNvSpPr>
+          <p:nvPr/>
+        </p:nvSpPr>
+        <p:spPr>
+          <a:xfrm>
+            <a:off x="685800" y="5314950"/>
+            <a:ext cx="10744200" cy="285750"/>
+          </a:xfrm>
+          <a:prstGeom prst="rect">
+            <a:avLst/>
+          </a:prstGeom>
+          <a:noFill/>
+          <a:ln w="0">
+            <a:noFill/>
+            <a:prstDash val="solid"/>
+          </a:ln>
+        </p:spPr>
+        <p:txBody>
+          <a:bodyPr lIns="0" tIns="19050" rIns="0" bIns="19050" anchor="ctr"/>
+          <a:lstStyle/>
+          <a:p>
+            <a:pPr algn="ctr">
+              <a:buNone/>
+              <a:defRPr sz="1600" b="1">
+                <a:solidFill>
+                  <a:srgbClr val="DB6C30"/>
+                </a:solidFill>
+                <a:latin typeface="FlandersArtSans-Bold"/>
+                <a:ea typeface="FlandersArtSans-Bold"/>
+                <a:cs typeface="FlandersArtSans-Bold"/>
+              </a:defRPr>
+            </a:pPr>
+            <a:r>
+              <a:rPr sz="1600" b="1">
+                <a:solidFill>
+                  <a:srgbClr val="DB6C30"/>
+                </a:solidFill>
+                <a:latin typeface="FlandersArtSans-Bold"/>
+                <a:ea typeface="FlandersArtSans-Bold"/>
+                <a:cs typeface="FlandersArtSans-Bold"/>
+              </a:rPr>
+              <a:t>Rule of thumb: established ML workflow → Lightning; learning or distributed mechanics → native PyTorch.</a:t>
+            </a:r>
+          </a:p>
+        </p:txBody>
+      </p:sp>
+    </p:spTree>
+    <p:extLst>
+      <p:ext uri="{BB962C8B-B14F-4D97-AF65-F5344CB8AC3E}">
+        <p14:creationId xmlns:p14="http://schemas.microsoft.com/office/powerpoint/2010/main" val="2452457733"/>
+      </p:ext>
+    </p:extLst>
+  </p:cSld>
+  <p:clrMapOvr>
+    <a:masterClrMapping/>
+  </p:clrMapOvr>
+</p:sld>
+</file>
+
+<file path=ppt/slides/slide58.xml><?xml version="1.0" encoding="utf-8"?>
+<p:sld xmlns:a="http://schemas.openxmlformats.org/drawingml/2006/main" xmlns:r="http://schemas.openxmlformats.org/officeDocument/2006/relationships" xmlns:p="http://schemas.openxmlformats.org/presentationml/2006/main">
+  <p:cSld>
+    <p:spTree>
+      <p:nvGrpSpPr>
+        <p:cNvPr id="1" name=""/>
+        <p:cNvGrpSpPr/>
+        <p:nvPr/>
+      </p:nvGrpSpPr>
+      <p:grpSpPr>
+        <a:xfrm>
+          <a:off x="0" y="0"/>
+          <a:ext cx="0" cy="0"/>
+          <a:chOff x="0" y="0"/>
+          <a:chExt cx="0" cy="0"/>
+        </a:xfrm>
+      </p:grpSpPr>
+      <p:sp>
+        <p:nvSpPr>
           <p:cNvPr id="2" name="Title 1"/>
           <p:cNvSpPr>
             <a:spLocks noGrp="1"/>
@@ -41835,7 +43213,7 @@
           <a:p>
             <a:fld id="{5A209D72-2E9D-49B0-8977-41DCCC66C0BB}" type="slidenum">
               <a:rPr lang="nl-BE" smtClean="0"/>
-              <a:t>57</a:t>
+              <a:t>58</a:t>
             </a:fld>
             <a:endParaRPr lang="nl-BE"/>
           </a:p>
@@ -42237,7 +43615,7 @@
 </p:sld>
 </file>
 
-<file path=ppt/slides/slide58.xml><?xml version="1.0" encoding="utf-8"?>
+<file path=ppt/slides/slide59.xml><?xml version="1.0" encoding="utf-8"?>
 <p:sld xmlns:a="http://schemas.openxmlformats.org/drawingml/2006/main" xmlns:r="http://schemas.openxmlformats.org/officeDocument/2006/relationships" xmlns:p="http://schemas.openxmlformats.org/presentationml/2006/main">
   <p:cSld>
     <p:spTree>
@@ -42414,7 +43792,7 @@
           <a:p>
             <a:fld id="{5A209D72-2E9D-49B0-8977-41DCCC66C0BB}" type="slidenum">
               <a:rPr lang="nl-BE" smtClean="0"/>
-              <a:t>58</a:t>
+              <a:t>59</a:t>
             </a:fld>
             <a:endParaRPr lang="nl-BE"/>
           </a:p>
@@ -42887,7 +44265,7 @@
 </p:sld>
 </file>
 
-<file path=ppt/slides/slide59.xml><?xml version="1.0" encoding="utf-8"?>
+<file path=ppt/slides/slide6.xml><?xml version="1.0" encoding="utf-8"?>
 <p:sld xmlns:a="http://schemas.openxmlformats.org/drawingml/2006/main" xmlns:r="http://schemas.openxmlformats.org/officeDocument/2006/relationships" xmlns:p="http://schemas.openxmlformats.org/presentationml/2006/main">
   <p:cSld>
     <p:spTree>
@@ -42921,6 +44299,151 @@
           <a:p>
             <a:r>
               <a:rPr lang="en-US" dirty="0"/>
+              <a:t>Regression</a:t>
+            </a:r>
+          </a:p>
+        </p:txBody>
+      </p:sp>
+      <p:sp>
+        <p:nvSpPr>
+          <p:cNvPr id="4" name="Text Placeholder 3"/>
+          <p:cNvSpPr>
+            <a:spLocks noGrp="1"/>
+          </p:cNvSpPr>
+          <p:nvPr>
+            <p:ph type="body" sz="half" idx="2"/>
+          </p:nvPr>
+        </p:nvSpPr>
+        <p:spPr/>
+        <p:txBody>
+          <a:bodyPr/>
+          <a:lstStyle/>
+          <a:p>
+            <a:r>
+              <a:rPr lang="en-US" dirty="0"/>
+              <a:t>Colorize B&amp;W images automatically</a:t>
+            </a:r>
+          </a:p>
+          <a:p>
+            <a:r>
+              <a:rPr lang="en-US" dirty="0">
+                <a:hlinkClick r:id="rId2"/>
+              </a:rPr>
+              <a:t>https://tinyclouds.org/colorize/</a:t>
+            </a:r>
+            <a:endParaRPr lang="en-US" dirty="0"/>
+          </a:p>
+        </p:txBody>
+      </p:sp>
+      <p:sp>
+        <p:nvSpPr>
+          <p:cNvPr id="5" name="Slide Number Placeholder 4"/>
+          <p:cNvSpPr>
+            <a:spLocks noGrp="1"/>
+          </p:cNvSpPr>
+          <p:nvPr>
+            <p:ph type="sldNum" sz="quarter" idx="12"/>
+          </p:nvPr>
+        </p:nvSpPr>
+        <p:spPr/>
+        <p:txBody>
+          <a:bodyPr/>
+          <a:lstStyle/>
+          <a:p>
+            <a:fld id="{CF5A1C33-475D-474A-A037-DDAF3DC7AF09}" type="slidenum">
+              <a:rPr lang="en-US" smtClean="0"/>
+              <a:t>6</a:t>
+            </a:fld>
+            <a:endParaRPr lang="en-US"/>
+          </a:p>
+        </p:txBody>
+      </p:sp>
+      <p:pic>
+        <p:nvPicPr>
+          <p:cNvPr id="1028" name="Picture 4" descr="Colorization of Black and White Photographs"/>
+          <p:cNvPicPr>
+            <a:picLocks noGrp="1" noChangeAspect="1" noChangeArrowheads="1"/>
+          </p:cNvPicPr>
+          <p:nvPr>
+            <p:ph type="pic" idx="1"/>
+          </p:nvPr>
+        </p:nvPicPr>
+        <p:blipFill>
+          <a:blip r:embed="rId3">
+            <a:extLst>
+              <a:ext uri="{28A0092B-C50C-407E-A947-70E740481C1C}">
+                <a14:useLocalDpi xmlns:a14="http://schemas.microsoft.com/office/drawing/2010/main" val="0"/>
+              </a:ext>
+            </a:extLst>
+          </a:blip>
+          <a:srcRect l="6201" r="6201"/>
+          <a:stretch>
+            <a:fillRect/>
+          </a:stretch>
+        </p:blipFill>
+        <p:spPr bwMode="auto">
+          <a:prstGeom prst="rect">
+            <a:avLst/>
+          </a:prstGeom>
+          <a:noFill/>
+          <a:extLst>
+            <a:ext uri="{909E8E84-426E-40DD-AFC4-6F175D3DCCD1}">
+              <a14:hiddenFill xmlns:a14="http://schemas.microsoft.com/office/drawing/2010/main">
+                <a:solidFill>
+                  <a:srgbClr val="FFFFFF"/>
+                </a:solidFill>
+              </a14:hiddenFill>
+            </a:ext>
+          </a:extLst>
+        </p:spPr>
+      </p:pic>
+    </p:spTree>
+    <p:extLst>
+      <p:ext uri="{BB962C8B-B14F-4D97-AF65-F5344CB8AC3E}">
+        <p14:creationId xmlns:p14="http://schemas.microsoft.com/office/powerpoint/2010/main" val="3625121773"/>
+      </p:ext>
+    </p:extLst>
+  </p:cSld>
+  <p:clrMapOvr>
+    <a:masterClrMapping/>
+  </p:clrMapOvr>
+</p:sld>
+</file>
+
+<file path=ppt/slides/slide60.xml><?xml version="1.0" encoding="utf-8"?>
+<p:sld xmlns:a="http://schemas.openxmlformats.org/drawingml/2006/main" xmlns:r="http://schemas.openxmlformats.org/officeDocument/2006/relationships" xmlns:p="http://schemas.openxmlformats.org/presentationml/2006/main">
+  <p:cSld>
+    <p:spTree>
+      <p:nvGrpSpPr>
+        <p:cNvPr id="1" name=""/>
+        <p:cNvGrpSpPr/>
+        <p:nvPr/>
+      </p:nvGrpSpPr>
+      <p:grpSpPr>
+        <a:xfrm>
+          <a:off x="0" y="0"/>
+          <a:ext cx="0" cy="0"/>
+          <a:chOff x="0" y="0"/>
+          <a:chExt cx="0" cy="0"/>
+        </a:xfrm>
+      </p:grpSpPr>
+      <p:sp>
+        <p:nvSpPr>
+          <p:cNvPr id="2" name="Title 1"/>
+          <p:cNvSpPr>
+            <a:spLocks noGrp="1"/>
+          </p:cNvSpPr>
+          <p:nvPr>
+            <p:ph type="title"/>
+          </p:nvPr>
+        </p:nvSpPr>
+        <p:spPr/>
+        <p:txBody>
+          <a:bodyPr/>
+          <a:lstStyle/>
+          <a:p>
+            <a:r>
+              <a:rPr lang="en-US" dirty="0"/>
               <a:t>Further reading</a:t>
             </a:r>
           </a:p>
@@ -43032,7 +44555,7 @@
           <a:p>
             <a:fld id="{5A209D72-2E9D-49B0-8977-41DCCC66C0BB}" type="slidenum">
               <a:rPr lang="nl-BE" smtClean="0"/>
-              <a:t>59</a:t>
+              <a:t>60</a:t>
             </a:fld>
             <a:endParaRPr lang="nl-BE"/>
           </a:p>
@@ -43234,152 +44757,7 @@
 </p:sld>
 </file>
 
-<file path=ppt/slides/slide6.xml><?xml version="1.0" encoding="utf-8"?>
-<p:sld xmlns:a="http://schemas.openxmlformats.org/drawingml/2006/main" xmlns:r="http://schemas.openxmlformats.org/officeDocument/2006/relationships" xmlns:p="http://schemas.openxmlformats.org/presentationml/2006/main">
-  <p:cSld>
-    <p:spTree>
-      <p:nvGrpSpPr>
-        <p:cNvPr id="1" name=""/>
-        <p:cNvGrpSpPr/>
-        <p:nvPr/>
-      </p:nvGrpSpPr>
-      <p:grpSpPr>
-        <a:xfrm>
-          <a:off x="0" y="0"/>
-          <a:ext cx="0" cy="0"/>
-          <a:chOff x="0" y="0"/>
-          <a:chExt cx="0" cy="0"/>
-        </a:xfrm>
-      </p:grpSpPr>
-      <p:sp>
-        <p:nvSpPr>
-          <p:cNvPr id="2" name="Title 1"/>
-          <p:cNvSpPr>
-            <a:spLocks noGrp="1"/>
-          </p:cNvSpPr>
-          <p:nvPr>
-            <p:ph type="title"/>
-          </p:nvPr>
-        </p:nvSpPr>
-        <p:spPr/>
-        <p:txBody>
-          <a:bodyPr/>
-          <a:lstStyle/>
-          <a:p>
-            <a:r>
-              <a:rPr lang="en-US" dirty="0"/>
-              <a:t>Regression</a:t>
-            </a:r>
-          </a:p>
-        </p:txBody>
-      </p:sp>
-      <p:sp>
-        <p:nvSpPr>
-          <p:cNvPr id="4" name="Text Placeholder 3"/>
-          <p:cNvSpPr>
-            <a:spLocks noGrp="1"/>
-          </p:cNvSpPr>
-          <p:nvPr>
-            <p:ph type="body" sz="half" idx="2"/>
-          </p:nvPr>
-        </p:nvSpPr>
-        <p:spPr/>
-        <p:txBody>
-          <a:bodyPr/>
-          <a:lstStyle/>
-          <a:p>
-            <a:r>
-              <a:rPr lang="en-US" dirty="0"/>
-              <a:t>Colorize B&amp;W images automatically</a:t>
-            </a:r>
-          </a:p>
-          <a:p>
-            <a:r>
-              <a:rPr lang="en-US" dirty="0">
-                <a:hlinkClick r:id="rId2"/>
-              </a:rPr>
-              <a:t>https://tinyclouds.org/colorize/</a:t>
-            </a:r>
-            <a:endParaRPr lang="en-US" dirty="0"/>
-          </a:p>
-        </p:txBody>
-      </p:sp>
-      <p:sp>
-        <p:nvSpPr>
-          <p:cNvPr id="5" name="Slide Number Placeholder 4"/>
-          <p:cNvSpPr>
-            <a:spLocks noGrp="1"/>
-          </p:cNvSpPr>
-          <p:nvPr>
-            <p:ph type="sldNum" sz="quarter" idx="12"/>
-          </p:nvPr>
-        </p:nvSpPr>
-        <p:spPr/>
-        <p:txBody>
-          <a:bodyPr/>
-          <a:lstStyle/>
-          <a:p>
-            <a:fld id="{CF5A1C33-475D-474A-A037-DDAF3DC7AF09}" type="slidenum">
-              <a:rPr lang="en-US" smtClean="0"/>
-              <a:t>6</a:t>
-            </a:fld>
-            <a:endParaRPr lang="en-US"/>
-          </a:p>
-        </p:txBody>
-      </p:sp>
-      <p:pic>
-        <p:nvPicPr>
-          <p:cNvPr id="1028" name="Picture 4" descr="Colorization of Black and White Photographs"/>
-          <p:cNvPicPr>
-            <a:picLocks noGrp="1" noChangeAspect="1" noChangeArrowheads="1"/>
-          </p:cNvPicPr>
-          <p:nvPr>
-            <p:ph type="pic" idx="1"/>
-          </p:nvPr>
-        </p:nvPicPr>
-        <p:blipFill>
-          <a:blip r:embed="rId3">
-            <a:extLst>
-              <a:ext uri="{28A0092B-C50C-407E-A947-70E740481C1C}">
-                <a14:useLocalDpi xmlns:a14="http://schemas.microsoft.com/office/drawing/2010/main" val="0"/>
-              </a:ext>
-            </a:extLst>
-          </a:blip>
-          <a:srcRect l="6201" r="6201"/>
-          <a:stretch>
-            <a:fillRect/>
-          </a:stretch>
-        </p:blipFill>
-        <p:spPr bwMode="auto">
-          <a:prstGeom prst="rect">
-            <a:avLst/>
-          </a:prstGeom>
-          <a:noFill/>
-          <a:extLst>
-            <a:ext uri="{909E8E84-426E-40DD-AFC4-6F175D3DCCD1}">
-              <a14:hiddenFill xmlns:a14="http://schemas.microsoft.com/office/drawing/2010/main">
-                <a:solidFill>
-                  <a:srgbClr val="FFFFFF"/>
-                </a:solidFill>
-              </a14:hiddenFill>
-            </a:ext>
-          </a:extLst>
-        </p:spPr>
-      </p:pic>
-    </p:spTree>
-    <p:extLst>
-      <p:ext uri="{BB962C8B-B14F-4D97-AF65-F5344CB8AC3E}">
-        <p14:creationId xmlns:p14="http://schemas.microsoft.com/office/powerpoint/2010/main" val="3625121773"/>
-      </p:ext>
-    </p:extLst>
-  </p:cSld>
-  <p:clrMapOvr>
-    <a:masterClrMapping/>
-  </p:clrMapOvr>
-</p:sld>
-</file>
-
-<file path=ppt/slides/slide60.xml><?xml version="1.0" encoding="utf-8"?>
+<file path=ppt/slides/slide61.xml><?xml version="1.0" encoding="utf-8"?>
 <p:sld xmlns:a="http://schemas.openxmlformats.org/drawingml/2006/main" xmlns:r="http://schemas.openxmlformats.org/officeDocument/2006/relationships" xmlns:p="http://schemas.openxmlformats.org/presentationml/2006/main">
   <p:cSld>
     <p:spTree>
@@ -43473,7 +44851,7 @@
           <a:p>
             <a:fld id="{5A209D72-2E9D-49B0-8977-41DCCC66C0BB}" type="slidenum">
               <a:rPr lang="nl-BE" smtClean="0"/>
-              <a:t>60</a:t>
+              <a:t>61</a:t>
             </a:fld>
             <a:endParaRPr lang="nl-BE"/>
           </a:p>
@@ -43492,7 +44870,7 @@
 </p:sld>
 </file>
 
-<file path=ppt/slides/slide61.xml><?xml version="1.0" encoding="utf-8"?>
+<file path=ppt/slides/slide62.xml><?xml version="1.0" encoding="utf-8"?>
 <p:sld xmlns:a="http://schemas.openxmlformats.org/drawingml/2006/main" xmlns:r="http://schemas.openxmlformats.org/officeDocument/2006/relationships" xmlns:p="http://schemas.openxmlformats.org/presentationml/2006/main">
   <p:cSld>
     <p:spTree>
@@ -43603,7 +44981,7 @@
           <a:p>
             <a:fld id="{5A209D72-2E9D-49B0-8977-41DCCC66C0BB}" type="slidenum">
               <a:rPr lang="nl-BE" smtClean="0"/>
-              <a:t>61</a:t>
+              <a:t>62</a:t>
             </a:fld>
             <a:endParaRPr lang="nl-BE"/>
           </a:p>
@@ -44313,7 +45691,7 @@
 </p:sld>
 </file>
 
-<file path=ppt/slides/slide62.xml><?xml version="1.0" encoding="utf-8"?>
+<file path=ppt/slides/slide63.xml><?xml version="1.0" encoding="utf-8"?>
 <p:sld xmlns:a="http://schemas.openxmlformats.org/drawingml/2006/main" xmlns:r="http://schemas.openxmlformats.org/officeDocument/2006/relationships" xmlns:p="http://schemas.openxmlformats.org/presentationml/2006/main">
   <p:cSld>
     <p:spTree>
@@ -44505,7 +45883,7 @@
           <a:p>
             <a:fld id="{CF5A1C33-475D-474A-A037-DDAF3DC7AF09}" type="slidenum">
               <a:rPr lang="en-US" smtClean="0"/>
-              <a:t>62</a:t>
+              <a:t>63</a:t>
             </a:fld>
             <a:endParaRPr lang="en-US"/>
           </a:p>
@@ -45014,7 +46392,7 @@
 </p:sld>
 </file>
 
-<file path=ppt/slides/slide63.xml><?xml version="1.0" encoding="utf-8"?>
+<file path=ppt/slides/slide64.xml><?xml version="1.0" encoding="utf-8"?>
 <p:sld xmlns:a="http://schemas.openxmlformats.org/drawingml/2006/main" xmlns:r="http://schemas.openxmlformats.org/officeDocument/2006/relationships" xmlns:p="http://schemas.openxmlformats.org/presentationml/2006/main">
   <p:cSld>
     <p:spTree>
@@ -45165,7 +46543,7 @@
           <a:p>
             <a:fld id="{CF5A1C33-475D-474A-A037-DDAF3DC7AF09}" type="slidenum">
               <a:rPr lang="en-US" smtClean="0"/>
-              <a:t>63</a:t>
+              <a:t>64</a:t>
             </a:fld>
             <a:endParaRPr lang="en-US"/>
           </a:p>
@@ -45601,7 +46979,7 @@
 </p:sld>
 </file>
 
-<file path=ppt/slides/slide64.xml><?xml version="1.0" encoding="utf-8"?>
+<file path=ppt/slides/slide65.xml><?xml version="1.0" encoding="utf-8"?>
 <p:sld xmlns:a="http://schemas.openxmlformats.org/drawingml/2006/main" xmlns:r="http://schemas.openxmlformats.org/officeDocument/2006/relationships" xmlns:p="http://schemas.openxmlformats.org/presentationml/2006/main">
   <p:cSld>
     <p:spTree>
@@ -45743,7 +47121,7 @@
           <a:p>
             <a:fld id="{5A209D72-2E9D-49B0-8977-41DCCC66C0BB}" type="slidenum">
               <a:rPr lang="nl-BE" smtClean="0"/>
-              <a:t>64</a:t>
+              <a:t>65</a:t>
             </a:fld>
             <a:endParaRPr lang="nl-BE"/>
           </a:p>
@@ -47173,7 +48551,7 @@
 </p:sld>
 </file>
 
-<file path=ppt/slides/slide65.xml><?xml version="1.0" encoding="utf-8"?>
+<file path=ppt/slides/slide66.xml><?xml version="1.0" encoding="utf-8"?>
 <p:sld xmlns:a="http://schemas.openxmlformats.org/drawingml/2006/main" xmlns:r="http://schemas.openxmlformats.org/officeDocument/2006/relationships" xmlns:p="http://schemas.openxmlformats.org/presentationml/2006/main">
   <p:cSld>
     <p:spTree>
@@ -47418,7 +48796,7 @@
           <a:p>
             <a:fld id="{CF5A1C33-475D-474A-A037-DDAF3DC7AF09}" type="slidenum">
               <a:rPr lang="en-US" smtClean="0"/>
-              <a:t>65</a:t>
+              <a:t>66</a:t>
             </a:fld>
             <a:endParaRPr lang="en-US"/>
           </a:p>

</xml_diff>